<commit_message>
docs+slides: presentation deck updates + README Presentation section
- loop_automation.pptx:
  * HIL slide: photo of the real Saleae + Curiosity Nano bench
  * CLI slide: generated PWM signal plot + green terminal-style panel (COM12/115200)
  * half-bridge slide: HS/LS dead-time plot from the smoke-test report
  * new slide "Why an LLM can configure a logic peripheral" (honest methodology + limits)
- README: add Presentation section + project-structure entry
- smoketest_report.html: refreshed
- .gitignore: ignore pptx backups and scratch image assets

Co-Authored-By: Claude Opus 4.8 <noreply@anthropic.com>
</commit_message>
<xml_diff>
--- a/loop_automation.pptx
+++ b/loop_automation.pptx
@@ -25,6 +25,11 @@
     <p:sldId id="267" r:id="rId23"/>
     <p:sldId id="268" r:id="rId24"/>
     <p:sldId id="269" r:id="rId25"/>
+    <p:sldId id="271" r:id="rId27"/>
+    <p:sldId id="272" r:id="rId28"/>
+    <p:sldId id="273" r:id="rId29"/>
+    <p:sldId id="274" r:id="rId30"/>
+    <p:sldId id="275" r:id="rId31"/>
     <p:sldId id="270" r:id="rId26"/>
   </p:sldIdLst>
   <p:sldSz cx="12188825" cy="6858000"/>
@@ -4486,6 +4491,7 @@
           <a:lstStyle/>
           <a:p>
             <a:r>
+              <a:rPr/>
               <a:t>Automated Build, Flash &amp; Test</a:t>
             </a:r>
           </a:p>
@@ -4507,16 +4513,19 @@
           <a:lstStyle/>
           <a:p>
             <a:r>
+              <a:rPr sz="1800"/>
               <a:t>A CLI- and logic-analyzer-driven workflow on the PIC16F13145 Curiosity Nano</a:t>
             </a:r>
           </a:p>
           <a:p>
             <a:r>
+              <a:rPr sz="1800"/>
               <a:t>Martin Ruppert | Microchip</a:t>
             </a:r>
           </a:p>
           <a:p>
             <a:r>
+              <a:rPr sz="1800"/>
               <a:t>2026-06-14</a:t>
             </a:r>
           </a:p>
@@ -4573,6 +4582,7 @@
           <a:lstStyle/>
           <a:p>
             <a:r>
+              <a:rPr/>
               <a:t>Smoke-Test Results</a:t>
             </a:r>
           </a:p>
@@ -4621,7 +4631,7 @@
           <a:p>
             <a:pPr algn="l"/>
             <a:r>
-              <a:rPr sz="2200" b="1" i="0">
+              <a:rPr sz="1800" b="1" i="0">
                 <a:solidFill>
                   <a:srgbClr val="FFFFFF"/>
                 </a:solidFill>
@@ -4675,7 +4685,7 @@
           <a:p>
             <a:pPr algn="l"/>
             <a:r>
-              <a:rPr sz="2200" b="1" i="0">
+              <a:rPr sz="1800" b="1" i="0">
                 <a:solidFill>
                   <a:srgbClr val="FFFFFF"/>
                 </a:solidFill>
@@ -4729,7 +4739,7 @@
           <a:p>
             <a:pPr algn="l"/>
             <a:r>
-              <a:rPr sz="2200" b="1" i="0">
+              <a:rPr sz="1800" b="1" i="0">
                 <a:solidFill>
                   <a:srgbClr val="FFFFFF"/>
                 </a:solidFill>
@@ -4783,7 +4793,7 @@
           <a:p>
             <a:pPr algn="l"/>
             <a:r>
-              <a:rPr sz="2200" b="1" i="0">
+              <a:rPr sz="1800" b="1" i="0">
                 <a:solidFill>
                   <a:srgbClr val="FFFFFF"/>
                 </a:solidFill>
@@ -4818,7 +4828,7 @@
           <a:p>
             <a:pPr/>
             <a:r>
-              <a:rPr sz="1500">
+              <a:rPr sz="1800">
                 <a:solidFill>
                   <a:srgbClr val="0B2E4F"/>
                 </a:solidFill>
@@ -4829,7 +4839,7 @@
           <a:p>
             <a:pPr/>
             <a:r>
-              <a:rPr sz="1500">
+              <a:rPr sz="1800">
                 <a:solidFill>
                   <a:srgbClr val="0B2E4F"/>
                 </a:solidFill>
@@ -4840,7 +4850,7 @@
           <a:p>
             <a:pPr/>
             <a:r>
-              <a:rPr sz="1500">
+              <a:rPr sz="1800">
                 <a:solidFill>
                   <a:srgbClr val="0B2E4F"/>
                 </a:solidFill>
@@ -4884,6 +4894,7 @@
           <a:lstStyle/>
           <a:p>
             <a:r>
+              <a:rPr/>
               <a:t>Frequency Sweep — Saleae-Verified</a:t>
             </a:r>
           </a:p>
@@ -4937,7 +4948,7 @@
           <a:p>
             <a:pPr/>
             <a:r>
-              <a:rPr sz="1300">
+              <a:rPr sz="1800">
                 <a:solidFill>
                   <a:srgbClr val="0B2E4F"/>
                 </a:solidFill>
@@ -4948,7 +4959,7 @@
           <a:p>
             <a:pPr/>
             <a:r>
-              <a:rPr sz="1300">
+              <a:rPr sz="1800">
                 <a:solidFill>
                   <a:srgbClr val="0B2E4F"/>
                 </a:solidFill>
@@ -4959,7 +4970,7 @@
           <a:p>
             <a:pPr/>
             <a:r>
-              <a:rPr sz="1300">
+              <a:rPr sz="1800">
                 <a:solidFill>
                   <a:srgbClr val="0B2E4F"/>
                 </a:solidFill>
@@ -5003,6 +5014,7 @@
           <a:lstStyle/>
           <a:p>
             <a:r>
+              <a:rPr/>
               <a:t>Duty-Cycle Sweep across Frequencies</a:t>
             </a:r>
           </a:p>
@@ -5056,7 +5068,7 @@
           <a:p>
             <a:pPr/>
             <a:r>
-              <a:rPr sz="1300">
+              <a:rPr sz="1800">
                 <a:solidFill>
                   <a:srgbClr val="0B2E4F"/>
                 </a:solidFill>
@@ -5067,7 +5079,7 @@
           <a:p>
             <a:pPr/>
             <a:r>
-              <a:rPr sz="1300">
+              <a:rPr sz="1800">
                 <a:solidFill>
                   <a:srgbClr val="0B2E4F"/>
                 </a:solidFill>
@@ -5078,7 +5090,7 @@
           <a:p>
             <a:pPr/>
             <a:r>
-              <a:rPr sz="1300">
+              <a:rPr sz="1800">
                 <a:solidFill>
                   <a:srgbClr val="0B2E4F"/>
                 </a:solidFill>
@@ -5122,6 +5134,7 @@
           <a:lstStyle/>
           <a:p>
             <a:r>
+              <a:rPr/>
               <a:t>Interpreting the Results — Quantisation vs. the Real World</a:t>
             </a:r>
           </a:p>
@@ -5170,7 +5183,7 @@
           <a:p>
             <a:pPr algn="l"/>
             <a:r>
-              <a:rPr sz="1300" b="1" i="1">
+              <a:rPr sz="1800" b="1" i="1">
                 <a:solidFill>
                   <a:srgbClr val="0B2E4F"/>
                 </a:solidFill>
@@ -5223,7 +5236,7 @@
           <a:p>
             <a:pPr algn="l"/>
             <a:r>
-              <a:rPr sz="1400" b="1" i="0">
+              <a:rPr sz="1800" b="1" i="0">
                 <a:solidFill>
                   <a:srgbClr val="FFFFFF"/>
                 </a:solidFill>
@@ -5276,7 +5289,7 @@
           <a:p>
             <a:pPr algn="l"/>
             <a:r>
-              <a:rPr sz="1400" b="1" i="0">
+              <a:rPr sz="1800" b="1" i="0">
                 <a:solidFill>
                   <a:srgbClr val="FFFFFF"/>
                 </a:solidFill>
@@ -5310,7 +5323,7 @@
           <a:p>
             <a:pPr/>
             <a:r>
-              <a:rPr sz="1300">
+              <a:rPr sz="1800">
                 <a:solidFill>
                   <a:srgbClr val="0B2E4F"/>
                 </a:solidFill>
@@ -5321,7 +5334,7 @@
           <a:p>
             <a:pPr/>
             <a:r>
-              <a:rPr sz="1300">
+              <a:rPr sz="1800">
                 <a:solidFill>
                   <a:srgbClr val="0B2E4F"/>
                 </a:solidFill>
@@ -5332,7 +5345,7 @@
           <a:p>
             <a:pPr lvl="1"/>
             <a:r>
-              <a:rPr sz="1200">
+              <a:rPr sz="1800">
                 <a:solidFill>
                   <a:srgbClr val="0B2E4F"/>
                 </a:solidFill>
@@ -5343,7 +5356,7 @@
           <a:p>
             <a:pPr/>
             <a:r>
-              <a:rPr sz="1300">
+              <a:rPr sz="1800">
                 <a:solidFill>
                   <a:srgbClr val="0B2E4F"/>
                 </a:solidFill>
@@ -5354,7 +5367,7 @@
           <a:p>
             <a:pPr/>
             <a:r>
-              <a:rPr sz="1300">
+              <a:rPr sz="1800">
                 <a:solidFill>
                   <a:srgbClr val="0B2E4F"/>
                 </a:solidFill>
@@ -5388,7 +5401,7 @@
           <a:p>
             <a:pPr/>
             <a:r>
-              <a:rPr sz="1300">
+              <a:rPr sz="1800">
                 <a:solidFill>
                   <a:srgbClr val="0B2E4F"/>
                 </a:solidFill>
@@ -5399,7 +5412,7 @@
           <a:p>
             <a:pPr/>
             <a:r>
-              <a:rPr sz="1300">
+              <a:rPr sz="1800">
                 <a:solidFill>
                   <a:srgbClr val="0B2E4F"/>
                 </a:solidFill>
@@ -5410,7 +5423,7 @@
           <a:p>
             <a:pPr lvl="1"/>
             <a:r>
-              <a:rPr sz="1200">
+              <a:rPr sz="1800">
                 <a:solidFill>
                   <a:srgbClr val="0B2E4F"/>
                 </a:solidFill>
@@ -5421,7 +5434,7 @@
           <a:p>
             <a:pPr/>
             <a:r>
-              <a:rPr sz="1300">
+              <a:rPr sz="1800">
                 <a:solidFill>
                   <a:srgbClr val="0B2E4F"/>
                 </a:solidFill>
@@ -5432,7 +5445,7 @@
           <a:p>
             <a:pPr/>
             <a:r>
-              <a:rPr sz="1300">
+              <a:rPr sz="1800">
                 <a:solidFill>
                   <a:srgbClr val="0B2E4F"/>
                 </a:solidFill>
@@ -5485,7 +5498,7 @@
           <a:p>
             <a:pPr algn="l"/>
             <a:r>
-              <a:rPr sz="1400" b="1" i="1">
+              <a:rPr sz="1800" b="1" i="1">
                 <a:solidFill>
                   <a:srgbClr val="0B2E4F"/>
                 </a:solidFill>
@@ -5529,6 +5542,7 @@
           <a:lstStyle/>
           <a:p>
             <a:r>
+              <a:rPr/>
               <a:t>run_ci.py — One Command, One HTML Protocol</a:t>
             </a:r>
           </a:p>
@@ -5577,7 +5591,7 @@
           <a:p>
             <a:pPr algn="l"/>
             <a:r>
-              <a:rPr sz="1200" b="1" i="0">
+              <a:rPr sz="1800" b="1" i="0">
                 <a:solidFill>
                   <a:srgbClr val="FFFFFF"/>
                 </a:solidFill>
@@ -5631,7 +5645,7 @@
           <a:p>
             <a:pPr algn="l"/>
             <a:r>
-              <a:rPr sz="1200" b="1" i="0">
+              <a:rPr sz="1800" b="1" i="0">
                 <a:solidFill>
                   <a:srgbClr val="FFFFFF"/>
                 </a:solidFill>
@@ -5685,7 +5699,7 @@
           <a:p>
             <a:pPr algn="l"/>
             <a:r>
-              <a:rPr sz="1200" b="1" i="0">
+              <a:rPr sz="1800" b="1" i="0">
                 <a:solidFill>
                   <a:srgbClr val="FFFFFF"/>
                 </a:solidFill>
@@ -5739,7 +5753,7 @@
           <a:p>
             <a:pPr algn="l"/>
             <a:r>
-              <a:rPr sz="1200" b="1" i="0">
+              <a:rPr sz="1800" b="1" i="0">
                 <a:solidFill>
                   <a:srgbClr val="FFFFFF"/>
                 </a:solidFill>
@@ -5793,7 +5807,7 @@
           <a:p>
             <a:pPr algn="l"/>
             <a:r>
-              <a:rPr sz="1200" b="1" i="0">
+              <a:rPr sz="1800" b="1" i="0">
                 <a:solidFill>
                   <a:srgbClr val="FFFFFF"/>
                 </a:solidFill>
@@ -5968,7 +5982,7 @@
           <a:p>
             <a:pPr/>
             <a:r>
-              <a:rPr sz="1300">
+              <a:rPr sz="1800">
                 <a:solidFill>
                   <a:srgbClr val="0B2E4F"/>
                 </a:solidFill>
@@ -5979,7 +5993,7 @@
           <a:p>
             <a:pPr/>
             <a:r>
-              <a:rPr sz="1300">
+              <a:rPr sz="1800">
                 <a:solidFill>
                   <a:srgbClr val="0B2E4F"/>
                 </a:solidFill>
@@ -5990,7 +6004,7 @@
           <a:p>
             <a:pPr/>
             <a:r>
-              <a:rPr sz="1300">
+              <a:rPr sz="1800">
                 <a:solidFill>
                   <a:srgbClr val="0B2E4F"/>
                 </a:solidFill>
@@ -6001,7 +6015,7 @@
           <a:p>
             <a:pPr/>
             <a:r>
-              <a:rPr sz="1300">
+              <a:rPr sz="1800">
                 <a:solidFill>
                   <a:srgbClr val="0B2E4F"/>
                 </a:solidFill>
@@ -6012,7 +6026,7 @@
           <a:p>
             <a:pPr/>
             <a:r>
-              <a:rPr sz="1300">
+              <a:rPr sz="1800">
                 <a:solidFill>
                   <a:srgbClr val="0B2E4F"/>
                 </a:solidFill>
@@ -6056,6 +6070,651 @@
           <a:lstStyle/>
           <a:p>
             <a:r>
+              <a:rPr/>
+              <a:t>Scaling to the CLB Half-Bridge</a:t>
+            </a:r>
+          </a:p>
+        </p:txBody>
+      </p:sp>
+      <p:sp>
+        <p:nvSpPr>
+          <p:cNvPr id="3" name="Content Placeholder 2"/>
+          <p:cNvSpPr>
+            <a:spLocks noGrp="1"/>
+          </p:cNvSpPr>
+          <p:nvPr>
+            <p:ph idx="13" sz="quarter"/>
+          </p:nvPr>
+        </p:nvSpPr>
+        <p:spPr/>
+        <p:txBody>
+          <a:bodyPr wrap="square"/>
+          <a:lstStyle/>
+          <a:p>
+            <a:pPr>
+              <a:defRPr sz="1800">
+                <a:latin typeface="Calibri"/>
+              </a:defRPr>
+            </a:pPr>
+            <a:r>
+              <a:rPr sz="1800">
+                <a:latin typeface="Calibri"/>
+              </a:rPr>
+              <a:t>The same build -&gt; flash -&gt; verify pipeline now drives a second peripheral.</a:t>
+            </a:r>
+          </a:p>
+          <a:p>
+            <a:pPr>
+              <a:defRPr sz="1800">
+                <a:latin typeface="Calibri"/>
+              </a:defRPr>
+            </a:pPr>
+            <a:r>
+              <a:rPr sz="1800">
+                <a:latin typeface="Calibri"/>
+              </a:rPr>
+              <a:t>Goal: a complementary half-bridge on RC0 (HS) / RC1 (LS) with a runtime-adjustable dead-time.</a:t>
+            </a:r>
+          </a:p>
+          <a:p>
+            <a:pPr>
+              <a:defRPr sz="1800">
+                <a:latin typeface="Calibri"/>
+              </a:defRPr>
+            </a:pPr>
+            <a:r>
+              <a:rPr sz="1800">
+                <a:latin typeface="Calibri"/>
+              </a:rPr>
+              <a:t>The PIC16F13145 has no CWG -&gt; built entirely from the on-chip fabric.</a:t>
+            </a:r>
+          </a:p>
+          <a:p>
+            <a:pPr>
+              <a:defRPr sz="1800">
+                <a:latin typeface="Calibri"/>
+              </a:defRPr>
+            </a:pPr>
+            <a:r>
+              <a:rPr sz="1800">
+                <a:latin typeface="Calibri"/>
+              </a:rPr>
+              <a:t>Same console, new commands:</a:t>
+            </a:r>
+          </a:p>
+          <a:p>
+            <a:pPr lvl="1">
+              <a:defRPr sz="1800">
+                <a:latin typeface="Calibri"/>
+              </a:defRPr>
+            </a:pPr>
+            <a:r>
+              <a:rPr sz="1800">
+                <a:latin typeface="Calibri"/>
+              </a:rPr>
+              <a:t>clb on | off</a:t>
+            </a:r>
+          </a:p>
+          <a:p>
+            <a:pPr lvl="1">
+              <a:defRPr sz="1800">
+                <a:latin typeface="Calibri"/>
+              </a:defRPr>
+            </a:pPr>
+            <a:r>
+              <a:rPr sz="1800">
+                <a:latin typeface="Calibri"/>
+              </a:rPr>
+              <a:t>clb dt &lt;0-255&gt;   (dead-time, live)</a:t>
+            </a:r>
+          </a:p>
+          <a:p>
+            <a:pPr lvl="1">
+              <a:defRPr sz="1800">
+                <a:latin typeface="Calibri"/>
+              </a:defRPr>
+            </a:pPr>
+            <a:r>
+              <a:rPr sz="1800">
+                <a:latin typeface="Calibri"/>
+              </a:rPr>
+              <a:t>clb freq &lt;0|1&gt;   (125 / 62.5 kHz, live)</a:t>
+            </a:r>
+          </a:p>
+          <a:p>
+            <a:pPr lvl="1">
+              <a:defRPr sz="1800">
+                <a:latin typeface="Calibri"/>
+              </a:defRPr>
+            </a:pPr>
+            <a:r>
+              <a:rPr sz="1800">
+                <a:latin typeface="Calibri"/>
+              </a:rPr>
+              <a:t>clb status</a:t>
+            </a:r>
+          </a:p>
+          <a:p>
+            <a:pPr>
+              <a:defRPr sz="1800">
+                <a:latin typeface="Calibri"/>
+              </a:defRPr>
+            </a:pPr>
+            <a:r>
+              <a:rPr sz="1800">
+                <a:latin typeface="Calibri"/>
+              </a:rPr>
+              <a:t>Probed on the analyzer: RC0-&gt;D0, RC1-&gt;D1, RC2-&gt;D2, RC3-&gt;D3.</a:t>
+            </a:r>
+          </a:p>
+        </p:txBody>
+      </p:sp>
+    </p:spTree>
+  </p:cSld>
+  <p:clrMapOvr>
+    <a:masterClrMapping/>
+  </p:clrMapOvr>
+</p:sld>
+</file>
+
+<file path=ppt/slides/slide16.xml><?xml version="1.0" encoding="utf-8"?>
+<p:sld xmlns:a="http://schemas.openxmlformats.org/drawingml/2006/main" xmlns:p="http://schemas.openxmlformats.org/presentationml/2006/main" xmlns:r="http://schemas.openxmlformats.org/officeDocument/2006/relationships">
+  <p:cSld>
+    <p:spTree>
+      <p:nvGrpSpPr>
+        <p:cNvPr id="1" name=""/>
+        <p:cNvGrpSpPr/>
+        <p:nvPr/>
+      </p:nvGrpSpPr>
+      <p:grpSpPr/>
+      <p:sp>
+        <p:nvSpPr>
+          <p:cNvPr id="2" name="Title 1"/>
+          <p:cNvSpPr>
+            <a:spLocks noGrp="1"/>
+          </p:cNvSpPr>
+          <p:nvPr>
+            <p:ph type="title"/>
+          </p:nvPr>
+        </p:nvSpPr>
+        <p:spPr/>
+        <p:txBody>
+          <a:bodyPr/>
+          <a:lstStyle/>
+          <a:p>
+            <a:r>
+              <a:rPr/>
+              <a:t>The CLB Half-Bridge - Design</a:t>
+            </a:r>
+          </a:p>
+        </p:txBody>
+      </p:sp>
+      <p:sp>
+        <p:nvSpPr>
+          <p:cNvPr id="3" name="Content Placeholder 2"/>
+          <p:cNvSpPr>
+            <a:spLocks noGrp="1"/>
+          </p:cNvSpPr>
+          <p:nvPr>
+            <p:ph idx="13" sz="quarter"/>
+          </p:nvPr>
+        </p:nvSpPr>
+        <p:spPr>
+          <a:xfrm>
+            <a:off x="457200" y="1371600"/>
+            <a:ext cx="5760720" cy="4937760"/>
+          </a:xfrm>
+        </p:spPr>
+        <p:txBody>
+          <a:bodyPr wrap="square"/>
+          <a:lstStyle/>
+          <a:p>
+            <a:pPr>
+              <a:defRPr sz="1800">
+                <a:latin typeface="Calibri"/>
+              </a:defRPr>
+            </a:pPr>
+            <a:r>
+              <a:rPr sz="1800">
+                <a:latin typeface="Calibri"/>
+              </a:rPr>
+              <a:t>CLB free-running counter -&gt; PWM carrier (125 / 62.5 kHz).</a:t>
+            </a:r>
+          </a:p>
+          <a:p>
+            <a:pPr>
+              <a:defRPr sz="1800">
+                <a:latin typeface="Calibri"/>
+              </a:defRPr>
+            </a:pPr>
+            <a:r>
+              <a:rPr sz="1800">
+                <a:latin typeface="Calibri"/>
+              </a:rPr>
+              <a:t>TMR2-HLT monostable, retriggered by every PWM edge -&gt; dead-time = dt x 31.25 ns.</a:t>
+            </a:r>
+          </a:p>
+          <a:p>
+            <a:pPr>
+              <a:defRPr sz="1800">
+                <a:latin typeface="Calibri"/>
+              </a:defRPr>
+            </a:pPr>
+            <a:r>
+              <a:rPr sz="1800">
+                <a:latin typeface="Calibri"/>
+              </a:rPr>
+              <a:t>Two CLC D-flip-flops build the complementary HS / LS.</a:t>
+            </a:r>
+          </a:p>
+          <a:p>
+            <a:pPr>
+              <a:defRPr sz="1800">
+                <a:latin typeface="Calibri"/>
+              </a:defRPr>
+            </a:pPr>
+            <a:r>
+              <a:rPr sz="1800">
+                <a:latin typeface="Calibri"/>
+              </a:rPr>
+              <a:t>HS only while PWM=1, LS only while PWM=0</a:t>
+            </a:r>
+          </a:p>
+          <a:p>
+            <a:pPr lvl="1">
+              <a:defRPr sz="1800">
+                <a:latin typeface="Calibri"/>
+              </a:defRPr>
+            </a:pPr>
+            <a:r>
+              <a:rPr sz="1800">
+                <a:latin typeface="Calibri"/>
+              </a:rPr>
+              <a:t>-&gt; non-overlap is guaranteed by construction (no shoot-through).</a:t>
+            </a:r>
+          </a:p>
+          <a:p>
+            <a:pPr>
+              <a:defRPr sz="1800">
+                <a:latin typeface="Calibri"/>
+              </a:defRPr>
+            </a:pPr>
+            <a:r>
+              <a:rPr sz="1800">
+                <a:latin typeface="Calibri"/>
+              </a:rPr>
+              <a:t>Frequency and dead-time are set independently and live.</a:t>
+            </a:r>
+          </a:p>
+        </p:txBody>
+      </p:sp>
+      <p:pic>
+        <p:nvPicPr>
+          <p:cNvPr id="4" name="Picture 3" descr="clb_blockdiagram.png"/>
+          <p:cNvPicPr>
+            <a:picLocks noChangeAspect="1"/>
+          </p:cNvPicPr>
+          <p:nvPr/>
+        </p:nvPicPr>
+        <p:blipFill>
+          <a:blip r:embed="rId2"/>
+          <a:stretch>
+            <a:fillRect/>
+          </a:stretch>
+        </p:blipFill>
+        <p:spPr>
+          <a:xfrm>
+            <a:off x="6400800" y="1554480"/>
+            <a:ext cx="5394960" cy="2802525"/>
+          </a:xfrm>
+          <a:prstGeom prst="rect">
+            <a:avLst/>
+          </a:prstGeom>
+        </p:spPr>
+      </p:pic>
+    </p:spTree>
+  </p:cSld>
+  <p:clrMapOvr>
+    <a:masterClrMapping/>
+  </p:clrMapOvr>
+</p:sld>
+</file>
+
+<file path=ppt/slides/slide17.xml><?xml version="1.0" encoding="utf-8"?>
+<p:sld xmlns:a="http://schemas.openxmlformats.org/drawingml/2006/main" xmlns:p="http://schemas.openxmlformats.org/presentationml/2006/main" xmlns:r="http://schemas.openxmlformats.org/officeDocument/2006/relationships">
+  <p:cSld>
+    <p:spTree>
+      <p:nvGrpSpPr>
+        <p:cNvPr id="1" name=""/>
+        <p:cNvGrpSpPr/>
+        <p:nvPr/>
+      </p:nvGrpSpPr>
+      <p:grpSpPr/>
+      <p:sp>
+        <p:nvSpPr>
+          <p:cNvPr id="2" name="Title 1"/>
+          <p:cNvSpPr>
+            <a:spLocks noGrp="1"/>
+          </p:cNvSpPr>
+          <p:nvPr>
+            <p:ph type="title"/>
+          </p:nvPr>
+        </p:nvSpPr>
+        <p:spPr/>
+        <p:txBody>
+          <a:bodyPr/>
+          <a:lstStyle/>
+          <a:p>
+            <a:r>
+              <a:rPr/>
+              <a:t>Half-Bridge - Measured (Hardware-in-the-Loop)</a:t>
+            </a:r>
+          </a:p>
+        </p:txBody>
+      </p:sp>
+      <p:sp>
+        <p:nvSpPr>
+          <p:cNvPr id="3" name="Content Placeholder 2"/>
+          <p:cNvSpPr>
+            <a:spLocks noGrp="1"/>
+          </p:cNvSpPr>
+          <p:nvPr>
+            <p:ph idx="13" sz="quarter"/>
+          </p:nvPr>
+        </p:nvSpPr>
+        <p:spPr>
+          <a:xfrm>
+            <a:off x="457200" y="1371600"/>
+            <a:ext cx="5760720" cy="4937760"/>
+          </a:xfrm>
+        </p:spPr>
+        <p:txBody>
+          <a:bodyPr wrap="square"/>
+          <a:lstStyle/>
+          <a:p>
+            <a:pPr>
+              <a:defRPr sz="1800">
+                <a:latin typeface="Calibri"/>
+              </a:defRPr>
+            </a:pPr>
+            <a:r>
+              <a:rPr sz="1800">
+                <a:latin typeface="Calibri"/>
+              </a:rPr>
+              <a:t>smoketest.py now sweeps 2 carriers x 6 dead-times, measured on the pins.</a:t>
+            </a:r>
+          </a:p>
+          <a:p>
+            <a:pPr>
+              <a:defRPr sz="1800">
+                <a:latin typeface="Calibri"/>
+              </a:defRPr>
+            </a:pPr>
+            <a:r>
+              <a:rPr sz="1800">
+                <a:latin typeface="Calibri"/>
+              </a:rPr>
+              <a:t>Dead-time tracks dt x 31.25 ns to within ~10 ns (one 100 MS/s sample).</a:t>
+            </a:r>
+          </a:p>
+          <a:p>
+            <a:pPr>
+              <a:defRPr sz="1800">
+                <a:latin typeface="Calibri"/>
+              </a:defRPr>
+            </a:pPr>
+            <a:r>
+              <a:rPr sz="1800">
+                <a:latin typeface="Calibri"/>
+              </a:rPr>
+              <a:t>Zero shoot-through (both-high = 0 ns) at every setting.</a:t>
+            </a:r>
+          </a:p>
+          <a:p>
+            <a:pPr>
+              <a:defRPr sz="1800">
+                <a:latin typeface="Calibri"/>
+              </a:defRPr>
+            </a:pPr>
+            <a:r>
+              <a:rPr sz="1800">
+                <a:latin typeface="Calibri"/>
+              </a:rPr>
+              <a:t>Carrier exact to the oscillator tolerance.</a:t>
+            </a:r>
+          </a:p>
+          <a:p>
+            <a:pPr>
+              <a:defRPr sz="1800">
+                <a:latin typeface="Calibri"/>
+              </a:defRPr>
+            </a:pPr>
+            <a:r>
+              <a:rPr sz="1800">
+                <a:latin typeface="Calibri"/>
+              </a:rPr>
+              <a:t>Results, accuracy verdicts and plots in smoketest_report.html.</a:t>
+            </a:r>
+          </a:p>
+        </p:txBody>
+      </p:sp>
+      <p:pic>
+        <p:nvPicPr>
+          <p:cNvPr id="4" name="Picture 3" descr="clb_deadtime_zoom.png"/>
+          <p:cNvPicPr>
+            <a:picLocks noChangeAspect="1"/>
+          </p:cNvPicPr>
+          <p:nvPr/>
+        </p:nvPicPr>
+        <p:blipFill>
+          <a:blip r:embed="rId2"/>
+          <a:stretch>
+            <a:fillRect/>
+          </a:stretch>
+        </p:blipFill>
+        <p:spPr>
+          <a:xfrm>
+            <a:off x="6400800" y="1554480"/>
+            <a:ext cx="5394960" cy="2157984"/>
+          </a:xfrm>
+          <a:prstGeom prst="rect">
+            <a:avLst/>
+          </a:prstGeom>
+        </p:spPr>
+      </p:pic>
+      <p:pic>
+        <p:nvPicPr>
+          <p:cNvPr id="5" name="Picture 4" descr="hb_hs_ls_zoom.png"/>
+          <p:cNvPicPr>
+            <a:picLocks noChangeAspect="1"/>
+          </p:cNvPicPr>
+          <p:nvPr/>
+        </p:nvPicPr>
+        <p:blipFill>
+          <a:blip r:embed="rId3"/>
+          <a:stretch>
+            <a:fillRect/>
+          </a:stretch>
+        </p:blipFill>
+        <p:spPr>
+          <a:xfrm>
+            <a:off x="6400800" y="3858768"/>
+            <a:ext cx="3922776" cy="2377440"/>
+          </a:xfrm>
+          <a:prstGeom prst="rect">
+            <a:avLst/>
+          </a:prstGeom>
+        </p:spPr>
+      </p:pic>
+    </p:spTree>
+  </p:cSld>
+  <p:clrMapOvr>
+    <a:masterClrMapping/>
+  </p:clrMapOvr>
+</p:sld>
+</file>
+
+<file path=ppt/slides/slide18.xml><?xml version="1.0" encoding="utf-8"?>
+<p:sld xmlns:a="http://schemas.openxmlformats.org/drawingml/2006/main" xmlns:p="http://schemas.openxmlformats.org/presentationml/2006/main" xmlns:r="http://schemas.openxmlformats.org/officeDocument/2006/relationships">
+  <p:cSld>
+    <p:spTree>
+      <p:nvGrpSpPr>
+        <p:cNvPr id="1" name=""/>
+        <p:cNvGrpSpPr/>
+        <p:nvPr/>
+      </p:nvGrpSpPr>
+      <p:grpSpPr/>
+      <p:sp>
+        <p:nvSpPr>
+          <p:cNvPr id="2" name="Title 1"/>
+          <p:cNvSpPr>
+            <a:spLocks noGrp="1"/>
+          </p:cNvSpPr>
+          <p:nvPr>
+            <p:ph type="title"/>
+          </p:nvPr>
+        </p:nvSpPr>
+        <p:spPr/>
+        <p:txBody>
+          <a:bodyPr/>
+          <a:lstStyle/>
+          <a:p>
+            <a:r>
+              <a:rPr/>
+              <a:t>What the CLB Can / Can't Do - Capability Map</a:t>
+            </a:r>
+          </a:p>
+        </p:txBody>
+      </p:sp>
+      <p:sp>
+        <p:nvSpPr>
+          <p:cNvPr id="3" name="Content Placeholder 2"/>
+          <p:cNvSpPr>
+            <a:spLocks noGrp="1"/>
+          </p:cNvSpPr>
+          <p:nvPr>
+            <p:ph idx="13" sz="quarter"/>
+          </p:nvPr>
+        </p:nvSpPr>
+        <p:spPr/>
+        <p:txBody>
+          <a:bodyPr wrap="square"/>
+          <a:lstStyle/>
+          <a:p>
+            <a:pPr>
+              <a:defRPr sz="1800">
+                <a:latin typeface="Calibri"/>
+              </a:defRPr>
+            </a:pPr>
+            <a:r>
+              <a:rPr sz="1800">
+                <a:latin typeface="Calibri"/>
+              </a:rPr>
+              <a:t>A two-gate suite (clb_analyze.py): synthesis (does it route?) + silicon (does it run?).</a:t>
+            </a:r>
+          </a:p>
+          <a:p>
+            <a:pPr>
+              <a:defRPr sz="1800">
+                <a:latin typeface="Calibri"/>
+              </a:defRPr>
+            </a:pPr>
+            <a:r>
+              <a:rPr sz="1800">
+                <a:latin typeface="Calibri"/>
+              </a:rPr>
+              <a:t>Reliable: a small free-running counter (&lt;=2 output taps), clocked internally or from a pin.</a:t>
+            </a:r>
+          </a:p>
+          <a:p>
+            <a:pPr>
+              <a:defRPr sz="1800">
+                <a:latin typeface="Calibri"/>
+              </a:defRPr>
+            </a:pPr>
+            <a:r>
+              <a:rPr sz="1800">
+                <a:latin typeface="Calibri"/>
+              </a:rPr>
+              <a:t>CLBSWIN software inputs work - once the CLBCON.BUSY write-handshake is honoured.</a:t>
+            </a:r>
+          </a:p>
+          <a:p>
+            <a:pPr>
+              <a:defRPr sz="1800">
+                <a:latin typeface="Calibri"/>
+              </a:defRPr>
+            </a:pPr>
+            <a:r>
+              <a:rPr sz="1800">
+                <a:latin typeface="Calibri"/>
+              </a:rPr>
+              <a:t>Programmable dividers route, but P&amp;R silently drops period bits -&gt; only ~4 frequencies.</a:t>
+            </a:r>
+          </a:p>
+          <a:p>
+            <a:pPr>
+              <a:defRPr sz="1800">
+                <a:latin typeface="Calibri"/>
+              </a:defRPr>
+            </a:pPr>
+            <a:r>
+              <a:rPr sz="1800">
+                <a:latin typeface="Calibri"/>
+              </a:rPr>
+              <a:t>Lesson: keep the counter in the CLB; build gating / dead-time in CLC + TMR2.</a:t>
+            </a:r>
+          </a:p>
+          <a:p>
+            <a:pPr>
+              <a:defRPr sz="1800">
+                <a:latin typeface="Calibri"/>
+              </a:defRPr>
+            </a:pPr>
+            <a:r>
+              <a:rPr sz="1800">
+                <a:latin typeface="Calibri"/>
+              </a:rPr>
+              <a:t>Full 'extended datasheet + errata' for a future engineer/AI: clb_description.md.</a:t>
+            </a:r>
+          </a:p>
+        </p:txBody>
+      </p:sp>
+    </p:spTree>
+  </p:cSld>
+  <p:clrMapOvr>
+    <a:masterClrMapping/>
+  </p:clrMapOvr>
+</p:sld>
+</file>
+
+<file path=ppt/slides/slide19.xml><?xml version="1.0" encoding="utf-8"?>
+<p:sld xmlns:a="http://schemas.openxmlformats.org/drawingml/2006/main" xmlns:p="http://schemas.openxmlformats.org/presentationml/2006/main" xmlns:r="http://schemas.openxmlformats.org/officeDocument/2006/relationships">
+  <p:cSld>
+    <p:spTree>
+      <p:nvGrpSpPr>
+        <p:cNvPr id="1" name=""/>
+        <p:cNvGrpSpPr/>
+        <p:nvPr/>
+      </p:nvGrpSpPr>
+      <p:grpSpPr/>
+      <p:sp>
+        <p:nvSpPr>
+          <p:cNvPr id="2" name="Title 1"/>
+          <p:cNvSpPr>
+            <a:spLocks noGrp="1"/>
+          </p:cNvSpPr>
+          <p:nvPr>
+            <p:ph type="title"/>
+          </p:nvPr>
+        </p:nvSpPr>
+        <p:spPr/>
+        <p:txBody>
+          <a:bodyPr/>
+          <a:lstStyle/>
+          <a:p>
+            <a:r>
+              <a:rPr/>
               <a:t>Takeaways</a:t>
             </a:r>
           </a:p>
@@ -6177,6 +6836,7 @@
           <a:lstStyle/>
           <a:p>
             <a:r>
+              <a:rPr/>
               <a:t>What We Built</a:t>
             </a:r>
           </a:p>
@@ -6210,78 +6870,232 @@
           <a:p>
             <a:pPr lvl="1"/>
             <a:r>
+              <a:rPr sz="1800">
+                <a:solidFill>
+                  <a:srgbClr val="0B2E4F"/>
+                </a:solidFill>
+              </a:rPr>
+              <a:t>PIC16F13145 Curiosity Nano, PWM1-&gt;RC0, PWM2-&gt;RC1 (Timer2)</a:t>
+            </a:r>
+          </a:p>
+          <a:p>
+            <a:pPr lvl="1"/>
+            <a:r>
+              <a:rPr sz="1800">
+                <a:solidFill>
+                  <a:srgbClr val="0B2E4F"/>
+                </a:solidFill>
+              </a:rPr>
+              <a:t>Commands: help / version / reset / pulse freq|duty|on|off|status</a:t>
+            </a:r>
+          </a:p>
+          <a:p>
+            <a:pPr lvl="1"/>
+            <a:r>
+              <a:rPr sz="1800">
+                <a:solidFill>
+                  <a:srgbClr val="0B2E4F"/>
+                </a:solidFill>
+              </a:rPr>
+              <a:t>Line editor with cursor, mid-line edit and 10-command history</a:t>
+            </a:r>
+          </a:p>
+          <a:p>
+            <a:pPr lvl="1"/>
+            <a:r>
+              <a:rPr sz="1800">
+                <a:solidFill>
+                  <a:srgbClr val="0B2E4F"/>
+                </a:solidFill>
+              </a:rPr>
+              <a:t>Build-timestamp banner identifies the running firmware</a:t>
+            </a:r>
+          </a:p>
+          <a:p>
+            <a:pPr/>
+            <a:r>
+              <a:rPr sz="1800">
+                <a:solidFill>
+                  <a:srgbClr val="0B2E4F"/>
+                </a:solidFill>
+              </a:rPr>
+              <a:t>Tooling — the whole loop runs from the command line</a:t>
+            </a:r>
+          </a:p>
+          <a:p>
+            <a:pPr lvl="1"/>
+            <a:r>
+              <a:rPr sz="1800">
+                <a:solidFill>
+                  <a:srgbClr val="0B2E4F"/>
+                </a:solidFill>
+              </a:rPr>
+              <a:t>build.bat (CMake+Ninja+XC8), flash.py (MPLAB MDB)</a:t>
+            </a:r>
+          </a:p>
+          <a:p>
+            <a:pPr lvl="1"/>
+            <a:r>
+              <a:rPr sz="1800">
+                <a:solidFill>
+                  <a:srgbClr val="0B2E4F"/>
+                </a:solidFill>
+              </a:rPr>
+              <a:t>smoketest.py, freq_sweep.py, duty_sweep.py (Saleae-verified)</a:t>
+            </a:r>
+          </a:p>
+        </p:txBody>
+      </p:sp>
+    </p:spTree>
+  </p:cSld>
+  <p:clrMapOvr>
+    <a:masterClrMapping/>
+  </p:clrMapOvr>
+</p:sld>
+</file>
+
+<file path=ppt/slides/slide20.xml><?xml version="1.0" encoding="utf-8"?>
+<p:sld xmlns:a="http://schemas.openxmlformats.org/drawingml/2006/main" xmlns:p="http://schemas.openxmlformats.org/presentationml/2006/main" xmlns:r="http://schemas.openxmlformats.org/officeDocument/2006/relationships">
+  <p:cSld>
+    <p:spTree>
+      <p:nvGrpSpPr>
+        <p:cNvPr id="1" name=""/>
+        <p:cNvGrpSpPr/>
+        <p:nvPr/>
+      </p:nvGrpSpPr>
+      <p:grpSpPr/>
+      <p:sp>
+        <p:nvSpPr>
+          <p:cNvPr id="2" name="Title 1"/>
+          <p:cNvSpPr>
+            <a:spLocks noGrp="1"/>
+          </p:cNvSpPr>
+          <p:nvPr>
+            <p:ph type="title"/>
+          </p:nvPr>
+        </p:nvSpPr>
+        <p:spPr/>
+        <p:txBody>
+          <a:bodyPr/>
+          <a:lstStyle/>
+          <a:p>
+            <a:r>
+              <a:t>Why an LLM Can Configure a Logic Peripheral</a:t>
+            </a:r>
+          </a:p>
+        </p:txBody>
+      </p:sp>
+      <p:sp>
+        <p:nvSpPr>
+          <p:cNvPr id="3" name="Content Placeholder 2"/>
+          <p:cNvSpPr>
+            <a:spLocks noGrp="1"/>
+          </p:cNvSpPr>
+          <p:nvPr>
+            <p:ph idx="13" sz="quarter"/>
+          </p:nvPr>
+        </p:nvSpPr>
+        <p:spPr/>
+        <p:txBody>
+          <a:bodyPr wrap="square"/>
+          <a:lstStyle/>
+          <a:p>
+            <a:pPr/>
+            <a:r>
+              <a:rPr sz="1800">
+                <a:latin typeface="Calibri"/>
+              </a:rPr>
+              <a:t>Register setup is documentation-driven pattern work</a:t>
+            </a:r>
+          </a:p>
+          <a:p>
+            <a:pPr lvl="1"/>
+            <a:r>
               <a:rPr sz="1600">
-                <a:solidFill>
-                  <a:srgbClr val="0B2E4F"/>
-                </a:solidFill>
-              </a:rPr>
-              <a:t>PIC16F13145 Curiosity Nano, PWM1-&gt;RC0, PWM2-&gt;RC1 (Timer2)</a:t>
+                <a:latin typeface="Calibri"/>
+              </a:rPr>
+              <a:t>Datasheet register tables -&gt; ordered SFR writes: CLBCON, CLBSWIN, PPS, TMR2/HLT</a:t>
             </a:r>
           </a:p>
           <a:p>
             <a:pPr lvl="1"/>
             <a:r>
               <a:rPr sz="1600">
-                <a:solidFill>
-                  <a:srgbClr val="0B2E4F"/>
-                </a:solidFill>
-              </a:rPr>
-              <a:t>Commands: help / version / reset / pulse freq|duty|on|off|status</a:t>
+                <a:latin typeface="Calibri"/>
+              </a:rPr>
+              <a:t>PIC / XC8 idioms + MCC-generated headers + existing project code as scaffold</a:t>
+            </a:r>
+          </a:p>
+          <a:p>
+            <a:pPr/>
+            <a:r>
+              <a:rPr sz="1800">
+                <a:latin typeface="Calibri"/>
+              </a:rPr>
+              <a:t>Knowledge came from tools, not the model's memory alone</a:t>
             </a:r>
           </a:p>
           <a:p>
             <a:pPr lvl="1"/>
             <a:r>
               <a:rPr sz="1600">
-                <a:solidFill>
-                  <a:srgbClr val="0B2E4F"/>
-                </a:solidFill>
-              </a:rPr>
-              <a:t>Line editor with cursor, mid-line edit and 10-command history</a:t>
+                <a:latin typeface="Calibri"/>
+              </a:rPr>
+              <a:t>Datasheet looked up live (e.g. the CLBCON.BUSY handshake); MCC register defs reused</a:t>
+            </a:r>
+          </a:p>
+          <a:p>
+            <a:pPr/>
+            <a:r>
+              <a:rPr sz="1800">
+                <a:latin typeface="Calibri"/>
+              </a:rPr>
+              <a:t>The hardware-in-the-loop did the heavy lifting</a:t>
             </a:r>
           </a:p>
           <a:p>
             <a:pPr lvl="1"/>
             <a:r>
               <a:rPr sz="1600">
-                <a:solidFill>
-                  <a:srgbClr val="0B2E4F"/>
-                </a:solidFill>
-              </a:rPr>
-              <a:t>Build-timestamp banner identifies the running firmware</a:t>
+                <a:latin typeface="Calibri"/>
+              </a:rPr>
+              <a:t>flash -&gt; measure (Saleae) -&gt; compare -&gt; fix exposed the real bugs:</a:t>
+            </a:r>
+          </a:p>
+          <a:p>
+            <a:pPr lvl="1"/>
+            <a:r>
+              <a:rPr sz="1600">
+                <a:latin typeface="Calibri"/>
+              </a:rPr>
+              <a:t>TMR2 prescaler (dead-time x32), missing BUSY handshake, PPS invert / off-by-one</a:t>
             </a:r>
           </a:p>
           <a:p>
             <a:pPr/>
             <a:r>
               <a:rPr sz="1800">
-                <a:solidFill>
-                  <a:srgbClr val="0B2E4F"/>
-                </a:solidFill>
-              </a:rPr>
-              <a:t>Tooling — the whole loop runs from the command line</a:t>
+                <a:latin typeface="Calibri"/>
+              </a:rPr>
+              <a:t>Honest limit: the CLB logic fabric is NOT generated headlessly</a:t>
             </a:r>
           </a:p>
           <a:p>
             <a:pPr lvl="1"/>
             <a:r>
               <a:rPr sz="1600">
-                <a:solidFill>
-                  <a:srgbClr val="0B2E4F"/>
-                </a:solidFill>
-              </a:rPr>
-              <a:t>build.bat (CMake+Ninja+XC8), flash.py (MPLAB MDB)</a:t>
+                <a:latin typeface="Calibri"/>
+              </a:rPr>
+              <a:t>Verilog is sent to pyclbsynthesizer (Microchip server); only a small counter routes reliably</a:t>
             </a:r>
           </a:p>
           <a:p>
             <a:pPr lvl="1"/>
             <a:r>
               <a:rPr sz="1600">
-                <a:solidFill>
-                  <a:srgbClr val="0B2E4F"/>
-                </a:solidFill>
-              </a:rPr>
-              <a:t>smoketest.py, freq_sweep.py, duty_sweep.py (Saleae-verified)</a:t>
+                <a:latin typeface="Calibri"/>
+              </a:rPr>
+              <a:t>"Configure the registers" is not the same as "synthesize the logic fabric"</a:t>
             </a:r>
           </a:p>
         </p:txBody>
@@ -6320,6 +7134,7 @@
           <a:lstStyle/>
           <a:p>
             <a:r>
+              <a:rPr/>
               <a:t>Manual vs. Automated</a:t>
             </a:r>
           </a:p>
@@ -6368,7 +7183,7 @@
           <a:p>
             <a:pPr algn="l"/>
             <a:r>
-              <a:rPr sz="1300" b="1" i="1">
+              <a:rPr sz="1800" b="1" i="1">
                 <a:solidFill>
                   <a:srgbClr val="0B2E4F"/>
                 </a:solidFill>
@@ -6421,7 +7236,7 @@
           <a:p>
             <a:pPr algn="l"/>
             <a:r>
-              <a:rPr sz="1400" b="1" i="0">
+              <a:rPr sz="1800" b="1" i="0">
                 <a:solidFill>
                   <a:srgbClr val="FFFFFF"/>
                 </a:solidFill>
@@ -6474,7 +7289,7 @@
           <a:p>
             <a:pPr algn="l"/>
             <a:r>
-              <a:rPr sz="1400" b="1" i="0">
+              <a:rPr sz="1800" b="1" i="0">
                 <a:solidFill>
                   <a:srgbClr val="FFFFFF"/>
                 </a:solidFill>
@@ -6508,7 +7323,7 @@
           <a:p>
             <a:pPr/>
             <a:r>
-              <a:rPr sz="1300">
+              <a:rPr sz="1800">
                 <a:solidFill>
                   <a:srgbClr val="0B2E4F"/>
                 </a:solidFill>
@@ -6519,7 +7334,7 @@
           <a:p>
             <a:pPr/>
             <a:r>
-              <a:rPr sz="1300">
+              <a:rPr sz="1800">
                 <a:solidFill>
                   <a:srgbClr val="0B2E4F"/>
                 </a:solidFill>
@@ -6530,7 +7345,7 @@
           <a:p>
             <a:pPr/>
             <a:r>
-              <a:rPr sz="1300">
+              <a:rPr sz="1800">
                 <a:solidFill>
                   <a:srgbClr val="0B2E4F"/>
                 </a:solidFill>
@@ -6541,7 +7356,7 @@
           <a:p>
             <a:pPr/>
             <a:r>
-              <a:rPr sz="1300">
+              <a:rPr sz="1800">
                 <a:solidFill>
                   <a:srgbClr val="0B2E4F"/>
                 </a:solidFill>
@@ -6575,7 +7390,7 @@
           <a:p>
             <a:pPr/>
             <a:r>
-              <a:rPr sz="1300">
+              <a:rPr sz="1800">
                 <a:solidFill>
                   <a:srgbClr val="0B2E4F"/>
                 </a:solidFill>
@@ -6586,7 +7401,7 @@
           <a:p>
             <a:pPr/>
             <a:r>
-              <a:rPr sz="1300">
+              <a:rPr sz="1800">
                 <a:solidFill>
                   <a:srgbClr val="0B2E4F"/>
                 </a:solidFill>
@@ -6597,7 +7412,7 @@
           <a:p>
             <a:pPr/>
             <a:r>
-              <a:rPr sz="1300">
+              <a:rPr sz="1800">
                 <a:solidFill>
                   <a:srgbClr val="0B2E4F"/>
                 </a:solidFill>
@@ -6608,7 +7423,7 @@
           <a:p>
             <a:pPr/>
             <a:r>
-              <a:rPr sz="1300">
+              <a:rPr sz="1800">
                 <a:solidFill>
                   <a:srgbClr val="0B2E4F"/>
                 </a:solidFill>
@@ -6661,7 +7476,7 @@
           <a:p>
             <a:pPr algn="l"/>
             <a:r>
-              <a:rPr sz="1400" b="1" i="1">
+              <a:rPr sz="1800" b="1" i="1">
                 <a:solidFill>
                   <a:srgbClr val="0B2E4F"/>
                 </a:solidFill>
@@ -6705,6 +7520,7 @@
           <a:lstStyle/>
           <a:p>
             <a:r>
+              <a:rPr/>
               <a:t>The Automated Pipeline</a:t>
             </a:r>
           </a:p>
@@ -6753,7 +7569,7 @@
           <a:p>
             <a:pPr algn="l"/>
             <a:r>
-              <a:rPr sz="1500" b="1" i="0">
+              <a:rPr sz="1800" b="1" i="0">
                 <a:solidFill>
                   <a:srgbClr val="FFFFFF"/>
                 </a:solidFill>
@@ -6806,7 +7622,7 @@
           <a:p>
             <a:pPr algn="l"/>
             <a:r>
-              <a:rPr sz="1500" b="1" i="0">
+              <a:rPr sz="1800" b="1" i="0">
                 <a:solidFill>
                   <a:srgbClr val="FFFFFF"/>
                 </a:solidFill>
@@ -6859,7 +7675,7 @@
           <a:p>
             <a:pPr algn="l"/>
             <a:r>
-              <a:rPr sz="1500" b="1" i="0">
+              <a:rPr sz="1800" b="1" i="0">
                 <a:solidFill>
                   <a:srgbClr val="FFFFFF"/>
                 </a:solidFill>
@@ -6912,7 +7728,7 @@
           <a:p>
             <a:pPr algn="l"/>
             <a:r>
-              <a:rPr sz="1500" b="1" i="0">
+              <a:rPr sz="1800" b="1" i="0">
                 <a:solidFill>
                   <a:srgbClr val="FFFFFF"/>
                 </a:solidFill>
@@ -7050,7 +7866,7 @@
           <a:lstStyle/>
           <a:p>
             <a:r>
-              <a:rPr sz="1200" b="0" i="0">
+              <a:rPr sz="1800" b="0" i="0">
                 <a:solidFill>
                   <a:srgbClr val="555555"/>
                 </a:solidFill>
@@ -7083,7 +7899,7 @@
           <a:lstStyle/>
           <a:p>
             <a:r>
-              <a:rPr sz="1200" b="0" i="0">
+              <a:rPr sz="1800" b="0" i="0">
                 <a:solidFill>
                   <a:srgbClr val="555555"/>
                 </a:solidFill>
@@ -7116,7 +7932,7 @@
           <a:lstStyle/>
           <a:p>
             <a:r>
-              <a:rPr sz="1200" b="0" i="0">
+              <a:rPr sz="1800" b="0" i="0">
                 <a:solidFill>
                   <a:srgbClr val="555555"/>
                 </a:solidFill>
@@ -7149,7 +7965,7 @@
           <a:lstStyle/>
           <a:p>
             <a:r>
-              <a:rPr sz="1200" b="0" i="0">
+              <a:rPr sz="1800" b="0" i="0">
                 <a:solidFill>
                   <a:srgbClr val="555555"/>
                 </a:solidFill>
@@ -7202,7 +8018,7 @@
           <a:p>
             <a:pPr algn="l"/>
             <a:r>
-              <a:rPr sz="1500" b="1" i="0">
+              <a:rPr sz="1800" b="1" i="0">
                 <a:solidFill>
                   <a:srgbClr val="FFFFFF"/>
                 </a:solidFill>
@@ -7246,6 +8062,7 @@
           <a:lstStyle/>
           <a:p>
             <a:r>
+              <a:rPr/>
               <a:t>1. Build from the CLI — build.bat</a:t>
             </a:r>
           </a:p>
@@ -7375,7 +8192,7 @@
           <a:p>
             <a:pPr/>
             <a:r>
-              <a:rPr sz="1300">
+              <a:rPr sz="1800">
                 <a:solidFill>
                   <a:srgbClr val="0B2E4F"/>
                 </a:solidFill>
@@ -7386,7 +8203,7 @@
           <a:p>
             <a:pPr/>
             <a:r>
-              <a:rPr sz="1300">
+              <a:rPr sz="1800">
                 <a:solidFill>
                   <a:srgbClr val="0B2E4F"/>
                 </a:solidFill>
@@ -7397,7 +8214,7 @@
           <a:p>
             <a:pPr/>
             <a:r>
-              <a:rPr sz="1300">
+              <a:rPr sz="1800">
                 <a:solidFill>
                   <a:srgbClr val="0B2E4F"/>
                 </a:solidFill>
@@ -7441,6 +8258,7 @@
           <a:lstStyle/>
           <a:p>
             <a:r>
+              <a:rPr/>
               <a:t>2. Flash from the CLI — flash.py (MPLAB MDB)</a:t>
             </a:r>
           </a:p>
@@ -7559,7 +8377,7 @@
           <a:p>
             <a:pPr/>
             <a:r>
-              <a:rPr sz="1300">
+              <a:rPr sz="1800">
                 <a:solidFill>
                   <a:srgbClr val="0B2E4F"/>
                 </a:solidFill>
@@ -7570,7 +8388,7 @@
           <a:p>
             <a:pPr/>
             <a:r>
-              <a:rPr sz="1300">
+              <a:rPr sz="1800">
                 <a:solidFill>
                   <a:srgbClr val="0B2E4F"/>
                 </a:solidFill>
@@ -7581,7 +8399,7 @@
           <a:p>
             <a:pPr/>
             <a:r>
-              <a:rPr sz="1300">
+              <a:rPr sz="1800">
                 <a:solidFill>
                   <a:srgbClr val="0B2E4F"/>
                 </a:solidFill>
@@ -7625,6 +8443,7 @@
           <a:lstStyle/>
           <a:p>
             <a:r>
+              <a:rPr/>
               <a:t>Hardware-in-the-Loop Test Setup</a:t>
             </a:r>
           </a:p>
@@ -7673,7 +8492,7 @@
           <a:p>
             <a:pPr algn="l"/>
             <a:r>
-              <a:rPr sz="1200" b="1" i="0">
+              <a:rPr sz="1800" b="1" i="0">
                 <a:solidFill>
                   <a:srgbClr val="FFFFFF"/>
                 </a:solidFill>
@@ -7727,7 +8546,7 @@
           <a:p>
             <a:pPr algn="l"/>
             <a:r>
-              <a:rPr sz="1200" b="1" i="0">
+              <a:rPr sz="1800" b="1" i="0">
                 <a:solidFill>
                   <a:srgbClr val="FFFFFF"/>
                 </a:solidFill>
@@ -7781,7 +8600,7 @@
           <a:p>
             <a:pPr algn="l"/>
             <a:r>
-              <a:rPr sz="1200" b="1" i="0">
+              <a:rPr sz="1800" b="1" i="0">
                 <a:solidFill>
                   <a:srgbClr val="FFFFFF"/>
                 </a:solidFill>
@@ -7835,7 +8654,7 @@
           <a:p>
             <a:pPr algn="l"/>
             <a:r>
-              <a:rPr sz="1200" b="1" i="0">
+              <a:rPr sz="1800" b="1" i="0">
                 <a:solidFill>
                   <a:srgbClr val="FFFFFF"/>
                 </a:solidFill>
@@ -7889,7 +8708,7 @@
           <a:p>
             <a:pPr algn="l"/>
             <a:r>
-              <a:rPr sz="1200" b="1" i="0">
+              <a:rPr sz="1800" b="1" i="0">
                 <a:solidFill>
                   <a:srgbClr val="FFFFFF"/>
                 </a:solidFill>
@@ -7943,7 +8762,7 @@
           <a:p>
             <a:pPr algn="l"/>
             <a:r>
-              <a:rPr sz="1200" b="1" i="0">
+              <a:rPr sz="1800" b="1" i="0">
                 <a:solidFill>
                   <a:srgbClr val="FFFFFF"/>
                 </a:solidFill>
@@ -8138,7 +8957,7 @@
         <p:spPr>
           <a:xfrm>
             <a:off x="457200" y="3108960"/>
-            <a:ext cx="11247120" cy="3200400"/>
+            <a:ext cx="8503920" cy="3200400"/>
           </a:xfrm>
           <a:prstGeom prst="rect">
             <a:avLst/>
@@ -8153,7 +8972,7 @@
           <a:p>
             <a:pPr/>
             <a:r>
-              <a:rPr sz="1300">
+              <a:rPr sz="1800">
                 <a:solidFill>
                   <a:srgbClr val="0B2E4F"/>
                 </a:solidFill>
@@ -8164,7 +8983,7 @@
           <a:p>
             <a:pPr/>
             <a:r>
-              <a:rPr sz="1300">
+              <a:rPr sz="1800">
                 <a:solidFill>
                   <a:srgbClr val="0B2E4F"/>
                 </a:solidFill>
@@ -8175,12 +8994,71 @@
           <a:p>
             <a:pPr/>
             <a:r>
-              <a:rPr sz="1300">
+              <a:rPr sz="1800">
                 <a:solidFill>
                   <a:srgbClr val="0B2E4F"/>
                 </a:solidFill>
               </a:rPr>
               <a:t>• One host process orchestrates both the serial console and the capture.</a:t>
+            </a:r>
+          </a:p>
+        </p:txBody>
+      </p:sp>
+      <p:pic>
+        <p:nvPicPr>
+          <p:cNvPr id="15" name="Picture 14" descr="clb_hil_bench.jpg"/>
+          <p:cNvPicPr>
+            <a:picLocks noChangeAspect="1"/>
+          </p:cNvPicPr>
+          <p:nvPr/>
+        </p:nvPicPr>
+        <p:blipFill>
+          <a:blip r:embed="rId2"/>
+          <a:stretch>
+            <a:fillRect/>
+          </a:stretch>
+        </p:blipFill>
+        <p:spPr>
+          <a:xfrm>
+            <a:off x="9827057" y="3017520"/>
+            <a:ext cx="1996135" cy="2606040"/>
+          </a:xfrm>
+          <a:prstGeom prst="rect">
+            <a:avLst/>
+          </a:prstGeom>
+        </p:spPr>
+      </p:pic>
+      <p:sp>
+        <p:nvSpPr>
+          <p:cNvPr id="16" name="TextBox 15"/>
+          <p:cNvSpPr txBox="1"/>
+          <p:nvPr/>
+        </p:nvSpPr>
+        <p:spPr>
+          <a:xfrm>
+            <a:off x="7708392" y="5660136"/>
+            <a:ext cx="4297680" cy="548640"/>
+          </a:xfrm>
+          <a:prstGeom prst="rect">
+            <a:avLst/>
+          </a:prstGeom>
+          <a:noFill/>
+        </p:spPr>
+        <p:txBody>
+          <a:bodyPr wrap="square">
+            <a:spAutoFit/>
+          </a:bodyPr>
+          <a:lstStyle/>
+          <a:p>
+            <a:pPr algn="ctr"/>
+            <a:r>
+              <a:rPr sz="1800" i="1">
+                <a:solidFill>
+                  <a:srgbClr val="595959"/>
+                </a:solidFill>
+                <a:latin typeface="Calibri"/>
+              </a:rPr>
+              <a:t>Real HIL bench: Saleae Logic + PIC16F13145 Curiosity Nano</a:t>
             </a:r>
           </a:p>
         </p:txBody>
@@ -8205,6 +9083,105 @@
       <p:grpSpPr/>
       <p:sp>
         <p:nvSpPr>
+          <p:cNvPr id="6" name="Rectangle 5"/>
+          <p:cNvSpPr/>
+          <p:nvPr/>
+        </p:nvSpPr>
+        <p:spPr>
+          <a:xfrm>
+            <a:off x="320040" y="1700784"/>
+            <a:ext cx="6355080" cy="3520440"/>
+          </a:xfrm>
+          <a:prstGeom prst="rect">
+            <a:avLst/>
+          </a:prstGeom>
+          <a:solidFill>
+            <a:srgbClr val="1E1E1E"/>
+          </a:solidFill>
+          <a:ln w="12700">
+            <a:solidFill>
+              <a:srgbClr val="3C3C3C"/>
+            </a:solidFill>
+          </a:ln>
+          <a:effectLst/>
+        </p:spPr>
+        <p:style>
+          <a:lnRef idx="1">
+            <a:schemeClr val="accent1"/>
+          </a:lnRef>
+          <a:fillRef idx="3">
+            <a:schemeClr val="accent1"/>
+          </a:fillRef>
+          <a:effectRef idx="2">
+            <a:schemeClr val="accent1"/>
+          </a:effectRef>
+          <a:fontRef idx="minor">
+            <a:schemeClr val="lt1"/>
+          </a:fontRef>
+        </p:style>
+        <p:txBody>
+          <a:bodyPr rtlCol="0" anchor="ctr"/>
+          <a:lstStyle/>
+          <a:p>
+            <a:pPr algn="ctr"/>
+          </a:p>
+        </p:txBody>
+      </p:sp>
+      <p:sp>
+        <p:nvSpPr>
+          <p:cNvPr id="7" name="Rectangle 6"/>
+          <p:cNvSpPr/>
+          <p:nvPr/>
+        </p:nvSpPr>
+        <p:spPr>
+          <a:xfrm>
+            <a:off x="320040" y="1371600"/>
+            <a:ext cx="6355080" cy="329184"/>
+          </a:xfrm>
+          <a:prstGeom prst="rect">
+            <a:avLst/>
+          </a:prstGeom>
+          <a:solidFill>
+            <a:srgbClr val="323233"/>
+          </a:solidFill>
+          <a:ln>
+            <a:noFill/>
+          </a:ln>
+          <a:effectLst/>
+        </p:spPr>
+        <p:style>
+          <a:lnRef idx="1">
+            <a:schemeClr val="accent1"/>
+          </a:lnRef>
+          <a:fillRef idx="3">
+            <a:schemeClr val="accent1"/>
+          </a:fillRef>
+          <a:effectRef idx="2">
+            <a:schemeClr val="accent1"/>
+          </a:effectRef>
+          <a:fontRef idx="minor">
+            <a:schemeClr val="lt1"/>
+          </a:fontRef>
+        </p:style>
+        <p:txBody>
+          <a:bodyPr rtlCol="0" anchor="ctr" wrap="none" lIns="101600" tIns="25400" bIns="25400"/>
+          <a:lstStyle/>
+          <a:p>
+            <a:pPr algn="l"/>
+            <a:r>
+              <a:rPr sz="1100">
+                <a:solidFill>
+                  <a:srgbClr val="86C586"/>
+                </a:solidFill>
+                <a:latin typeface="Consolas"/>
+              </a:rPr>
+              <a:t>COM12 - 115200 baud  8N1</a:t>
+            </a:r>
+          </a:p>
+        </p:txBody>
+      </p:sp>
+      <p:sp>
+        <p:nvSpPr>
           <p:cNvPr id="2" name="Title 1"/>
           <p:cNvSpPr>
             <a:spLocks noGrp="1"/>
@@ -8219,6 +9196,7 @@
           <a:lstStyle/>
           <a:p>
             <a:r>
+              <a:rPr/>
               <a:t>The CLI Under Test</a:t>
             </a:r>
           </a:p>
@@ -8232,8 +9210,8 @@
         </p:nvSpPr>
         <p:spPr>
           <a:xfrm>
-            <a:off x="365760" y="1371600"/>
-            <a:ext cx="11430000" cy="3657600"/>
+            <a:off x="548640" y="1828800"/>
+            <a:ext cx="5897880" cy="3657600"/>
           </a:xfrm>
           <a:prstGeom prst="rect">
             <a:avLst/>
@@ -8241,7 +9219,7 @@
           <a:noFill/>
         </p:spPr>
         <p:txBody>
-          <a:bodyPr wrap="none">
+          <a:bodyPr wrap="none" lIns="76200" rIns="50800">
             <a:spAutoFit/>
           </a:bodyPr>
           <a:lstStyle/>
@@ -8249,7 +9227,7 @@
             <a:r>
               <a:rPr sz="1300">
                 <a:solidFill>
-                  <a:srgbClr val="0B2E4F"/>
+                  <a:srgbClr val="33FF66"/>
                 </a:solidFill>
                 <a:latin typeface="Consolas"/>
               </a:rPr>
@@ -8260,7 +9238,7 @@
             <a:r>
               <a:rPr sz="1300">
                 <a:solidFill>
-                  <a:srgbClr val="0B2E4F"/>
+                  <a:srgbClr val="33FF66"/>
                 </a:solidFill>
                 <a:latin typeface="Consolas"/>
               </a:rPr>
@@ -8271,7 +9249,7 @@
             <a:r>
               <a:rPr sz="1300">
                 <a:solidFill>
-                  <a:srgbClr val="0B2E4F"/>
+                  <a:srgbClr val="33FF66"/>
                 </a:solidFill>
                 <a:latin typeface="Consolas"/>
               </a:rPr>
@@ -8282,7 +9260,7 @@
             <a:r>
               <a:rPr sz="1300">
                 <a:solidFill>
-                  <a:srgbClr val="0B2E4F"/>
+                  <a:srgbClr val="33FF66"/>
                 </a:solidFill>
                 <a:latin typeface="Consolas"/>
               </a:rPr>
@@ -8293,7 +9271,7 @@
             <a:r>
               <a:rPr sz="1300">
                 <a:solidFill>
-                  <a:srgbClr val="0B2E4F"/>
+                  <a:srgbClr val="33FF66"/>
                 </a:solidFill>
                 <a:latin typeface="Consolas"/>
               </a:rPr>
@@ -8304,7 +9282,7 @@
             <a:r>
               <a:rPr sz="1300">
                 <a:solidFill>
-                  <a:srgbClr val="0B2E4F"/>
+                  <a:srgbClr val="33FF66"/>
                 </a:solidFill>
                 <a:latin typeface="Consolas"/>
               </a:rPr>
@@ -8315,7 +9293,7 @@
             <a:r>
               <a:rPr sz="1300">
                 <a:solidFill>
-                  <a:srgbClr val="0B2E4F"/>
+                  <a:srgbClr val="33FF66"/>
                 </a:solidFill>
                 <a:latin typeface="Consolas"/>
               </a:rPr>
@@ -8326,7 +9304,7 @@
             <a:r>
               <a:rPr sz="1300">
                 <a:solidFill>
-                  <a:srgbClr val="0B2E4F"/>
+                  <a:srgbClr val="33FF66"/>
                 </a:solidFill>
                 <a:latin typeface="Consolas"/>
               </a:rPr>
@@ -8337,7 +9315,7 @@
             <a:r>
               <a:rPr sz="1300">
                 <a:solidFill>
-                  <a:srgbClr val="0B2E4F"/>
+                  <a:srgbClr val="33FF66"/>
                 </a:solidFill>
                 <a:latin typeface="Consolas"/>
               </a:rPr>
@@ -8348,7 +9326,7 @@
             <a:r>
               <a:rPr sz="1300">
                 <a:solidFill>
-                  <a:srgbClr val="0B2E4F"/>
+                  <a:srgbClr val="33FF66"/>
                 </a:solidFill>
                 <a:latin typeface="Consolas"/>
               </a:rPr>
@@ -8359,11 +9337,22 @@
             <a:r>
               <a:rPr sz="1300">
                 <a:solidFill>
-                  <a:srgbClr val="0B2E4F"/>
+                  <a:srgbClr val="33FF66"/>
                 </a:solidFill>
                 <a:latin typeface="Consolas"/>
               </a:rPr>
               <a:t>A (RC0): ON, duty 33.293 %</a:t>
+            </a:r>
+          </a:p>
+          <a:p>
+            <a:r>
+              <a:rPr sz="1300">
+                <a:solidFill>
+                  <a:srgbClr val="33FF66"/>
+                </a:solidFill>
+                <a:latin typeface="Consolas"/>
+              </a:rPr>
+              <a:t>&gt; █</a:t>
             </a:r>
           </a:p>
         </p:txBody>
@@ -8392,7 +9381,7 @@
           <a:p>
             <a:pPr/>
             <a:r>
-              <a:rPr sz="1300">
+              <a:rPr sz="1800">
                 <a:solidFill>
                   <a:srgbClr val="0B2E4F"/>
                 </a:solidFill>
@@ -8403,12 +9392,71 @@
           <a:p>
             <a:pPr/>
             <a:r>
-              <a:rPr sz="1300">
+              <a:rPr sz="1800">
                 <a:solidFill>
                   <a:srgbClr val="0B2E4F"/>
                 </a:solidFill>
               </a:rPr>
               <a:t>• Scripts parse these replies as the expected reference for each test.</a:t>
+            </a:r>
+          </a:p>
+        </p:txBody>
+      </p:sp>
+      <p:pic>
+        <p:nvPicPr>
+          <p:cNvPr id="5" name="Picture 4" descr="slide8_signal.png"/>
+          <p:cNvPicPr>
+            <a:picLocks noChangeAspect="1"/>
+          </p:cNvPicPr>
+          <p:nvPr/>
+        </p:nvPicPr>
+        <p:blipFill>
+          <a:blip r:embed="rId2"/>
+          <a:stretch>
+            <a:fillRect/>
+          </a:stretch>
+        </p:blipFill>
+        <p:spPr>
+          <a:xfrm>
+            <a:off x="6812280" y="1554480"/>
+            <a:ext cx="4937760" cy="2117750"/>
+          </a:xfrm>
+          <a:prstGeom prst="rect">
+            <a:avLst/>
+          </a:prstGeom>
+        </p:spPr>
+      </p:pic>
+      <p:sp>
+        <p:nvSpPr>
+          <p:cNvPr id="8" name="TextBox 7"/>
+          <p:cNvSpPr txBox="1"/>
+          <p:nvPr/>
+        </p:nvSpPr>
+        <p:spPr>
+          <a:xfrm>
+            <a:off x="5577840" y="1371600"/>
+            <a:ext cx="1051560" cy="329184"/>
+          </a:xfrm>
+          <a:prstGeom prst="rect">
+            <a:avLst/>
+          </a:prstGeom>
+          <a:noFill/>
+        </p:spPr>
+        <p:txBody>
+          <a:bodyPr wrap="none" anchor="ctr" tIns="0" bIns="0" rIns="76200">
+            <a:spAutoFit/>
+          </a:bodyPr>
+          <a:lstStyle/>
+          <a:p>
+            <a:pPr algn="r"/>
+            <a:r>
+              <a:rPr sz="1100">
+                <a:solidFill>
+                  <a:srgbClr val="86C586"/>
+                </a:solidFill>
+                <a:latin typeface="Consolas"/>
+              </a:rPr>
+              <a:t>–  □  ×</a:t>
             </a:r>
           </a:p>
         </p:txBody>
@@ -8447,6 +9495,7 @@
           <a:lstStyle/>
           <a:p>
             <a:r>
+              <a:rPr/>
               <a:t>3. Verify — smoketest.py drives CLI + Saleae</a:t>
             </a:r>
           </a:p>
@@ -8609,7 +9658,7 @@
           <a:p>
             <a:pPr/>
             <a:r>
-              <a:rPr sz="1300">
+              <a:rPr sz="1800">
                 <a:solidFill>
                   <a:srgbClr val="0B2E4F"/>
                 </a:solidFill>
@@ -8620,7 +9669,7 @@
           <a:p>
             <a:pPr/>
             <a:r>
-              <a:rPr sz="1300">
+              <a:rPr sz="1800">
                 <a:solidFill>
                   <a:srgbClr val="0B2E4F"/>
                 </a:solidFill>

</xml_diff>